<commit_message>
Fix slide 13: align code annotation numbers + colors with the three cards
- Numbered the cards (1/2/3) to match the code comments top-to-bottom
- Recolored code comments to match each card (indigo/teal/amber)
- Removed the unmapped #2/#3/#4 annotations; schema/handler now neutral
</commit_message>
<xml_diff>
--- a/claude-certified-architect/Topic1_Agentic_Apps_Agent_SDK/Agentic_Apps_Claude_Agent_SDK.pptx
+++ b/claude-certified-architect/Topic1_Agentic_Apps_Agent_SDK/Agentic_Apps_Claude_Agent_SDK.pptx
@@ -7620,13 +7620,13 @@
             <a:r>
               <a:rPr lang="en-US" sz="1200" dirty="0">
                 <a:solidFill>
-                  <a:srgbClr val="FCD34D"/>
+                  <a:srgbClr val="A5B4FC"/>
                 </a:solidFill>
                 <a:latin typeface="Courier New" pitchFamily="34" charset="0"/>
                 <a:ea typeface="Courier New" pitchFamily="34" charset="-122"/>
                 <a:cs typeface="Courier New" pitchFamily="34" charset="-120"/>
               </a:rPr>
-              <a:t>  "lookup_order",</a:t>
+              <a:t>  "lookup_order",            # 1 namespaced name</a:t>
             </a:r>
             <a:endParaRPr lang="en-US" sz="1200" dirty="0"/>
           </a:p>
@@ -7640,7 +7640,7 @@
             <a:r>
               <a:rPr lang="en-US" sz="1200" dirty="0">
                 <a:solidFill>
-                  <a:srgbClr val="6EE7B7"/>
+                  <a:srgbClr val="5EEAD4"/>
                 </a:solidFill>
                 <a:latin typeface="Courier New" pitchFamily="34" charset="0"/>
                 <a:ea typeface="Courier New" pitchFamily="34" charset="-122"/>
@@ -7660,13 +7660,13 @@
             <a:r>
               <a:rPr lang="en-US" sz="1200" dirty="0">
                 <a:solidFill>
-                  <a:srgbClr val="6EE7B7"/>
+                  <a:srgbClr val="5EEAD4"/>
                 </a:solidFill>
                 <a:latin typeface="Courier New" pitchFamily="34" charset="0"/>
                 <a:ea typeface="Courier New" pitchFamily="34" charset="-122"/>
                 <a:cs typeface="Courier New" pitchFamily="34" charset="-120"/>
               </a:rPr>
-              <a:t>  " Returns total, status, customer. NOT for"</a:t>
+              <a:t>  " Returns total, status, customer. NOT"</a:t>
             </a:r>
             <a:endParaRPr lang="en-US" sz="1200" dirty="0"/>
           </a:p>
@@ -7680,13 +7680,13 @@
             <a:r>
               <a:rPr lang="en-US" sz="1200" dirty="0">
                 <a:solidFill>
-                  <a:srgbClr val="6EE7B7"/>
+                  <a:srgbClr val="5EEAD4"/>
                 </a:solidFill>
                 <a:latin typeface="Courier New" pitchFamily="34" charset="0"/>
                 <a:ea typeface="Courier New" pitchFamily="34" charset="-122"/>
                 <a:cs typeface="Courier New" pitchFamily="34" charset="-120"/>
               </a:rPr>
-              <a:t>  " customer lookups.",   # 1 differentiating desc</a:t>
+              <a:t>  " for customer lookups.",   # 2 selection signal</a:t>
             </a:r>
             <a:endParaRPr lang="en-US" sz="1200" dirty="0"/>
           </a:p>
@@ -7706,7 +7706,7 @@
                 <a:ea typeface="Courier New" pitchFamily="34" charset="-122"/>
                 <a:cs typeface="Courier New" pitchFamily="34" charset="-120"/>
               </a:rPr>
-              <a:t>  {"order_id": str})        # 2 input schema</a:t>
+              <a:t>  {"order_id": str})          # typed input schema</a:t>
             </a:r>
             <a:endParaRPr lang="en-US" sz="1200" dirty="0"/>
           </a:p>
@@ -7726,7 +7726,7 @@
                 <a:ea typeface="Courier New" pitchFamily="34" charset="-122"/>
                 <a:cs typeface="Courier New" pitchFamily="34" charset="-120"/>
               </a:rPr>
-              <a:t>async def lookup_order(args):   # 3 handler</a:t>
+              <a:t>async def lookup_order(args):  # handler</a:t>
             </a:r>
             <a:endParaRPr lang="en-US" sz="1200" dirty="0"/>
           </a:p>
@@ -7800,13 +7800,13 @@
             <a:r>
               <a:rPr lang="en-US" sz="1200" dirty="0">
                 <a:solidFill>
-                  <a:srgbClr val="FCA5A5"/>
+                  <a:srgbClr val="FCD34D"/>
                 </a:solidFill>
                 <a:latin typeface="Courier New" pitchFamily="34" charset="0"/>
                 <a:ea typeface="Courier New" pitchFamily="34" charset="-122"/>
                 <a:cs typeface="Courier New" pitchFamily="34" charset="-120"/>
               </a:rPr>
-              <a:t>                "is_error": True}   # 4 recoverable</a:t>
+              <a:t>                "is_error": True}  # 3 recoverable</a:t>
             </a:r>
             <a:endParaRPr lang="en-US" sz="1200" dirty="0"/>
           </a:p>
@@ -7874,14 +7874,14 @@
         </p:nvSpPr>
         <p:spPr>
           <a:xfrm>
-            <a:off x="7818120" y="1636776"/>
-            <a:ext cx="256032" cy="256032"/>
+            <a:off x="7818120" y="1600200"/>
+            <a:ext cx="457200" cy="457200"/>
           </a:xfrm>
           <a:prstGeom prst="ellipse">
             <a:avLst/>
           </a:prstGeom>
           <a:solidFill>
-            <a:srgbClr val="14B8A6"/>
+            <a:srgbClr val="4F46E5"/>
           </a:solidFill>
           <a:ln/>
         </p:spPr>
@@ -7894,8 +7894,47 @@
         </p:nvSpPr>
         <p:spPr>
           <a:xfrm>
-            <a:off x="8183880" y="1600200"/>
-            <a:ext cx="3291840" cy="411480"/>
+            <a:off x="7818120" y="1600200"/>
+            <a:ext cx="457200" cy="457200"/>
+          </a:xfrm>
+          <a:prstGeom prst="rect">
+            <a:avLst/>
+          </a:prstGeom>
+          <a:noFill/>
+          <a:ln/>
+        </p:spPr>
+        <p:txBody>
+          <a:bodyPr wrap="square" lIns="0" tIns="0" rIns="0" bIns="0" rtlCol="0" anchor="ctr"/>
+          <a:lstStyle/>
+          <a:p>
+            <a:pPr algn="ctr" indent="0" marL="0">
+              <a:buNone/>
+            </a:pPr>
+            <a:r>
+              <a:rPr lang="en-US" sz="1800" b="1" dirty="0">
+                <a:solidFill>
+                  <a:srgbClr val="FFFFFF"/>
+                </a:solidFill>
+                <a:latin typeface="Calibri" pitchFamily="34" charset="0"/>
+                <a:ea typeface="Calibri" pitchFamily="34" charset="-122"/>
+                <a:cs typeface="Calibri" pitchFamily="34" charset="-120"/>
+              </a:rPr>
+              <a:t>1</a:t>
+            </a:r>
+            <a:endParaRPr lang="en-US" sz="1800" dirty="0"/>
+          </a:p>
+        </p:txBody>
+      </p:sp>
+      <p:sp>
+        <p:nvSpPr>
+          <p:cNvPr id="10" name="Text 8"/>
+          <p:cNvSpPr/>
+          <p:nvPr/>
+        </p:nvSpPr>
+        <p:spPr>
+          <a:xfrm>
+            <a:off x="8412480" y="1618488"/>
+            <a:ext cx="3108960" cy="411480"/>
           </a:xfrm>
           <a:prstGeom prst="rect">
             <a:avLst/>
@@ -7919,7 +7958,7 @@
                 <a:ea typeface="Calibri" pitchFamily="34" charset="-122"/>
                 <a:cs typeface="Calibri" pitchFamily="34" charset="-120"/>
               </a:rPr>
-              <a:t>Description = selection signal</a:t>
+              <a:t>Namespaced name</a:t>
             </a:r>
             <a:endParaRPr lang="en-US" sz="1300" dirty="0"/>
           </a:p>
@@ -7927,14 +7966,14 @@
       </p:sp>
       <p:sp>
         <p:nvSpPr>
-          <p:cNvPr id="10" name="Text 8"/>
-          <p:cNvSpPr/>
-          <p:nvPr/>
-        </p:nvSpPr>
-        <p:spPr>
-          <a:xfrm>
-            <a:off x="7818120" y="2093976"/>
-            <a:ext cx="3611880" cy="640080"/>
+          <p:cNvPr id="11" name="Text 9"/>
+          <p:cNvSpPr/>
+          <p:nvPr/>
+        </p:nvSpPr>
+        <p:spPr>
+          <a:xfrm>
+            <a:off x="7818120" y="2130552"/>
+            <a:ext cx="3611880" cy="603504"/>
           </a:xfrm>
           <a:prstGeom prst="rect">
             <a:avLst/>
@@ -7948,12 +7987,12 @@
           <a:p>
             <a:pPr indent="0" marL="0">
               <a:lnSpc>
-                <a:spcPct val="105000"/>
+                <a:spcPct val="104000"/>
               </a:lnSpc>
               <a:buNone/>
             </a:pPr>
             <a:r>
-              <a:rPr lang="en-US" sz="1150" dirty="0">
+              <a:rPr lang="en-US" sz="1100" dirty="0">
                 <a:solidFill>
                   <a:srgbClr val="64748B"/>
                 </a:solidFill>
@@ -7961,15 +8000,15 @@
                 <a:ea typeface="Calibri" pitchFamily="34" charset="-122"/>
                 <a:cs typeface="Calibri" pitchFamily="34" charset="-120"/>
               </a:rPr>
-              <a:t>Distinct, bounded text. The model routes on this.</a:t>
-            </a:r>
-            <a:endParaRPr lang="en-US" sz="1150" dirty="0"/>
-          </a:p>
-        </p:txBody>
-      </p:sp>
-      <p:sp>
-        <p:nvSpPr>
-          <p:cNvPr id="11" name="Shape 9"/>
+              <a:t>Becomes mcp__support__lookup_order; list it in allowed_tools and scope per agent.</a:t>
+            </a:r>
+            <a:endParaRPr lang="en-US" sz="1100" dirty="0"/>
+          </a:p>
+        </p:txBody>
+      </p:sp>
+      <p:sp>
+        <p:nvSpPr>
+          <p:cNvPr id="12" name="Shape 10"/>
           <p:cNvSpPr/>
           <p:nvPr/>
         </p:nvSpPr>
@@ -8003,34 +8042,73 @@
       </p:sp>
       <p:sp>
         <p:nvSpPr>
-          <p:cNvPr id="12" name="Shape 10"/>
-          <p:cNvSpPr/>
-          <p:nvPr/>
-        </p:nvSpPr>
-        <p:spPr>
-          <a:xfrm>
-            <a:off x="7818120" y="3191256"/>
-            <a:ext cx="256032" cy="256032"/>
+          <p:cNvPr id="13" name="Shape 11"/>
+          <p:cNvSpPr/>
+          <p:nvPr/>
+        </p:nvSpPr>
+        <p:spPr>
+          <a:xfrm>
+            <a:off x="7818120" y="3154680"/>
+            <a:ext cx="457200" cy="457200"/>
           </a:xfrm>
           <a:prstGeom prst="ellipse">
             <a:avLst/>
           </a:prstGeom>
           <a:solidFill>
-            <a:srgbClr val="4F46E5"/>
+            <a:srgbClr val="14B8A6"/>
           </a:solidFill>
           <a:ln/>
         </p:spPr>
       </p:sp>
       <p:sp>
         <p:nvSpPr>
-          <p:cNvPr id="13" name="Text 11"/>
-          <p:cNvSpPr/>
-          <p:nvPr/>
-        </p:nvSpPr>
-        <p:spPr>
-          <a:xfrm>
-            <a:off x="8183880" y="3154680"/>
-            <a:ext cx="3291840" cy="411480"/>
+          <p:cNvPr id="14" name="Text 12"/>
+          <p:cNvSpPr/>
+          <p:nvPr/>
+        </p:nvSpPr>
+        <p:spPr>
+          <a:xfrm>
+            <a:off x="7818120" y="3154680"/>
+            <a:ext cx="457200" cy="457200"/>
+          </a:xfrm>
+          <a:prstGeom prst="rect">
+            <a:avLst/>
+          </a:prstGeom>
+          <a:noFill/>
+          <a:ln/>
+        </p:spPr>
+        <p:txBody>
+          <a:bodyPr wrap="square" lIns="0" tIns="0" rIns="0" bIns="0" rtlCol="0" anchor="ctr"/>
+          <a:lstStyle/>
+          <a:p>
+            <a:pPr algn="ctr" indent="0" marL="0">
+              <a:buNone/>
+            </a:pPr>
+            <a:r>
+              <a:rPr lang="en-US" sz="1800" b="1" dirty="0">
+                <a:solidFill>
+                  <a:srgbClr val="FFFFFF"/>
+                </a:solidFill>
+                <a:latin typeface="Calibri" pitchFamily="34" charset="0"/>
+                <a:ea typeface="Calibri" pitchFamily="34" charset="-122"/>
+                <a:cs typeface="Calibri" pitchFamily="34" charset="-120"/>
+              </a:rPr>
+              <a:t>2</a:t>
+            </a:r>
+            <a:endParaRPr lang="en-US" sz="1800" dirty="0"/>
+          </a:p>
+        </p:txBody>
+      </p:sp>
+      <p:sp>
+        <p:nvSpPr>
+          <p:cNvPr id="15" name="Text 13"/>
+          <p:cNvSpPr/>
+          <p:nvPr/>
+        </p:nvSpPr>
+        <p:spPr>
+          <a:xfrm>
+            <a:off x="8412480" y="3172968"/>
+            <a:ext cx="3108960" cy="411480"/>
           </a:xfrm>
           <a:prstGeom prst="rect">
             <a:avLst/>
@@ -8054,7 +8132,7 @@
                 <a:ea typeface="Calibri" pitchFamily="34" charset="-122"/>
                 <a:cs typeface="Calibri" pitchFamily="34" charset="-120"/>
               </a:rPr>
-              <a:t>Namespaced + scoped</a:t>
+              <a:t>Description = selection signal</a:t>
             </a:r>
             <a:endParaRPr lang="en-US" sz="1300" dirty="0"/>
           </a:p>
@@ -8062,14 +8140,14 @@
       </p:sp>
       <p:sp>
         <p:nvSpPr>
-          <p:cNvPr id="14" name="Text 12"/>
-          <p:cNvSpPr/>
-          <p:nvPr/>
-        </p:nvSpPr>
-        <p:spPr>
-          <a:xfrm>
-            <a:off x="7818120" y="3648456"/>
-            <a:ext cx="3611880" cy="640080"/>
+          <p:cNvPr id="16" name="Text 14"/>
+          <p:cNvSpPr/>
+          <p:nvPr/>
+        </p:nvSpPr>
+        <p:spPr>
+          <a:xfrm>
+            <a:off x="7818120" y="3685032"/>
+            <a:ext cx="3611880" cy="603504"/>
           </a:xfrm>
           <a:prstGeom prst="rect">
             <a:avLst/>
@@ -8083,12 +8161,12 @@
           <a:p>
             <a:pPr indent="0" marL="0">
               <a:lnSpc>
-                <a:spcPct val="105000"/>
+                <a:spcPct val="104000"/>
               </a:lnSpc>
               <a:buNone/>
             </a:pPr>
             <a:r>
-              <a:rPr lang="en-US" sz="1150" dirty="0">
+              <a:rPr lang="en-US" sz="1100" dirty="0">
                 <a:solidFill>
                   <a:srgbClr val="64748B"/>
                 </a:solidFill>
@@ -8096,15 +8174,15 @@
                 <a:ea typeface="Calibri" pitchFamily="34" charset="-122"/>
                 <a:cs typeface="Calibri" pitchFamily="34" charset="-120"/>
               </a:rPr>
-              <a:t>mcp__support__lookup_order in allowed_tools.</a:t>
-            </a:r>
-            <a:endParaRPr lang="en-US" sz="1150" dirty="0"/>
-          </a:p>
-        </p:txBody>
-      </p:sp>
-      <p:sp>
-        <p:nvSpPr>
-          <p:cNvPr id="15" name="Shape 13"/>
+              <a:t>Distinct, bounded text — the model routes between tools on this.</a:t>
+            </a:r>
+            <a:endParaRPr lang="en-US" sz="1100" dirty="0"/>
+          </a:p>
+        </p:txBody>
+      </p:sp>
+      <p:sp>
+        <p:nvSpPr>
+          <p:cNvPr id="17" name="Shape 15"/>
           <p:cNvSpPr/>
           <p:nvPr/>
         </p:nvSpPr>
@@ -8138,14 +8216,14 @@
       </p:sp>
       <p:sp>
         <p:nvSpPr>
-          <p:cNvPr id="16" name="Shape 14"/>
-          <p:cNvSpPr/>
-          <p:nvPr/>
-        </p:nvSpPr>
-        <p:spPr>
-          <a:xfrm>
-            <a:off x="7818120" y="4745736"/>
-            <a:ext cx="256032" cy="256032"/>
+          <p:cNvPr id="18" name="Shape 16"/>
+          <p:cNvSpPr/>
+          <p:nvPr/>
+        </p:nvSpPr>
+        <p:spPr>
+          <a:xfrm>
+            <a:off x="7818120" y="4709160"/>
+            <a:ext cx="457200" cy="457200"/>
           </a:xfrm>
           <a:prstGeom prst="ellipse">
             <a:avLst/>
@@ -8158,14 +8236,53 @@
       </p:sp>
       <p:sp>
         <p:nvSpPr>
-          <p:cNvPr id="17" name="Text 15"/>
-          <p:cNvSpPr/>
-          <p:nvPr/>
-        </p:nvSpPr>
-        <p:spPr>
-          <a:xfrm>
-            <a:off x="8183880" y="4709160"/>
-            <a:ext cx="3291840" cy="411480"/>
+          <p:cNvPr id="19" name="Text 17"/>
+          <p:cNvSpPr/>
+          <p:nvPr/>
+        </p:nvSpPr>
+        <p:spPr>
+          <a:xfrm>
+            <a:off x="7818120" y="4709160"/>
+            <a:ext cx="457200" cy="457200"/>
+          </a:xfrm>
+          <a:prstGeom prst="rect">
+            <a:avLst/>
+          </a:prstGeom>
+          <a:noFill/>
+          <a:ln/>
+        </p:spPr>
+        <p:txBody>
+          <a:bodyPr wrap="square" lIns="0" tIns="0" rIns="0" bIns="0" rtlCol="0" anchor="ctr"/>
+          <a:lstStyle/>
+          <a:p>
+            <a:pPr algn="ctr" indent="0" marL="0">
+              <a:buNone/>
+            </a:pPr>
+            <a:r>
+              <a:rPr lang="en-US" sz="1800" b="1" dirty="0">
+                <a:solidFill>
+                  <a:srgbClr val="FFFFFF"/>
+                </a:solidFill>
+                <a:latin typeface="Calibri" pitchFamily="34" charset="0"/>
+                <a:ea typeface="Calibri" pitchFamily="34" charset="-122"/>
+                <a:cs typeface="Calibri" pitchFamily="34" charset="-120"/>
+              </a:rPr>
+              <a:t>3</a:t>
+            </a:r>
+            <a:endParaRPr lang="en-US" sz="1800" dirty="0"/>
+          </a:p>
+        </p:txBody>
+      </p:sp>
+      <p:sp>
+        <p:nvSpPr>
+          <p:cNvPr id="20" name="Text 18"/>
+          <p:cNvSpPr/>
+          <p:nvPr/>
+        </p:nvSpPr>
+        <p:spPr>
+          <a:xfrm>
+            <a:off x="8412480" y="4727448"/>
+            <a:ext cx="3108960" cy="411480"/>
           </a:xfrm>
           <a:prstGeom prst="rect">
             <a:avLst/>
@@ -8197,14 +8314,14 @@
       </p:sp>
       <p:sp>
         <p:nvSpPr>
-          <p:cNvPr id="18" name="Text 16"/>
-          <p:cNvSpPr/>
-          <p:nvPr/>
-        </p:nvSpPr>
-        <p:spPr>
-          <a:xfrm>
-            <a:off x="7818120" y="5202936"/>
-            <a:ext cx="3611880" cy="640080"/>
+          <p:cNvPr id="21" name="Text 19"/>
+          <p:cNvSpPr/>
+          <p:nvPr/>
+        </p:nvSpPr>
+        <p:spPr>
+          <a:xfrm>
+            <a:off x="7818120" y="5239512"/>
+            <a:ext cx="3611880" cy="603504"/>
           </a:xfrm>
           <a:prstGeom prst="rect">
             <a:avLst/>
@@ -8218,12 +8335,12 @@
           <a:p>
             <a:pPr indent="0" marL="0">
               <a:lnSpc>
-                <a:spcPct val="105000"/>
+                <a:spcPct val="104000"/>
               </a:lnSpc>
               <a:buNone/>
             </a:pPr>
             <a:r>
-              <a:rPr lang="en-US" sz="1150" dirty="0">
+              <a:rPr lang="en-US" sz="1100" dirty="0">
                 <a:solidFill>
                   <a:srgbClr val="64748B"/>
                 </a:solidFill>
@@ -8231,15 +8348,15 @@
                 <a:ea typeface="Calibri" pitchFamily="34" charset="-122"/>
                 <a:cs typeface="Calibri" pitchFamily="34" charset="-120"/>
               </a:rPr>
-              <a:t>is_error keeps the loop alive so the agent recovers.</a:t>
-            </a:r>
-            <a:endParaRPr lang="en-US" sz="1150" dirty="0"/>
-          </a:p>
-        </p:txBody>
-      </p:sp>
-      <p:sp>
-        <p:nvSpPr>
-          <p:cNvPr id="19" name="Text 17"/>
+              <a:t>is_error keeps the loop alive so the agent can recover.</a:t>
+            </a:r>
+            <a:endParaRPr lang="en-US" sz="1100" dirty="0"/>
+          </a:p>
+        </p:txBody>
+      </p:sp>
+      <p:sp>
+        <p:nvSpPr>
+          <p:cNvPr id="22" name="Text 20"/>
           <p:cNvSpPr/>
           <p:nvPr/>
         </p:nvSpPr>
@@ -8278,7 +8395,7 @@
       </p:sp>
       <p:sp>
         <p:nvSpPr>
-          <p:cNvPr id="20" name="Text 18"/>
+          <p:cNvPr id="23" name="Text 21"/>
           <p:cNvSpPr/>
           <p:nvPr/>
         </p:nvSpPr>
@@ -8317,7 +8434,7 @@
       </p:sp>
       <p:sp>
         <p:nvSpPr>
-          <p:cNvPr id="21" name="Text 19"/>
+          <p:cNvPr id="24" name="Text 22"/>
           <p:cNvSpPr/>
           <p:nvPr/>
         </p:nvSpPr>

</xml_diff>

<commit_message>
Align code annotations with cards on all walkthrough slides (8, 18, 24, 25)
- Numbered comments now ascend top-to-bottom and map 1:1 to the cards
- Code comment colors matched to each card's badge/dot color
- Slide 24: cards re-mapped to rule / deny / reason (was mislabeled)
- Slide 25: additionalContext card recolored to match its highlighted line
</commit_message>
<xml_diff>
--- a/claude-certified-architect/Topic1_Agentic_Apps_Agent_SDK/Agentic_Apps_Claude_Agent_SDK.pptx
+++ b/claude-certified-architect/Topic1_Agentic_Apps_Agent_SDK/Agentic_Apps_Claude_Agent_SDK.pptx
@@ -12661,7 +12661,7 @@
             <a:r>
               <a:rPr lang="en-US" sz="1150" dirty="0">
                 <a:solidFill>
-                  <a:srgbClr val="FCD34D"/>
+                  <a:srgbClr val="FCA5A5"/>
                 </a:solidFill>
                 <a:latin typeface="Courier New" pitchFamily="34" charset="0"/>
                 <a:ea typeface="Courier New" pitchFamily="34" charset="-122"/>
@@ -12701,13 +12701,13 @@
             <a:r>
               <a:rPr lang="en-US" sz="1150" dirty="0">
                 <a:solidFill>
-                  <a:srgbClr val="C4B5FD"/>
+                  <a:srgbClr val="A5B4FC"/>
                 </a:solidFill>
                 <a:latin typeface="Courier New" pitchFamily="34" charset="0"/>
                 <a:ea typeface="Courier New" pitchFamily="34" charset="-122"/>
                 <a:cs typeface="Courier New" pitchFamily="34" charset="-120"/>
               </a:rPr>
-              <a:t>    "web-researcher": AgentDefinition(  # 2</a:t>
+              <a:t>    "web-researcher": AgentDefinition(   # 2</a:t>
             </a:r>
             <a:endParaRPr lang="en-US" sz="1150" dirty="0"/>
           </a:p>
@@ -12761,13 +12761,13 @@
             <a:r>
               <a:rPr lang="en-US" sz="1150" dirty="0">
                 <a:solidFill>
-                  <a:srgbClr val="7DD3FC"/>
+                  <a:srgbClr val="5EEAD4"/>
                 </a:solidFill>
                 <a:latin typeface="Courier New" pitchFamily="34" charset="0"/>
                 <a:ea typeface="Courier New" pitchFamily="34" charset="-122"/>
                 <a:cs typeface="Courier New" pitchFamily="34" charset="-120"/>
               </a:rPr>
-              <a:t>      tools=["WebSearch","Read"],  # 3 scoped</a:t>
+              <a:t>      tools=["WebSearch","Read"],   # 3 scoped</a:t>
             </a:r>
             <a:endParaRPr lang="en-US" sz="1150" dirty="0"/>
           </a:p>
@@ -12801,7 +12801,7 @@
             <a:r>
               <a:rPr lang="en-US" sz="1150" dirty="0">
                 <a:solidFill>
-                  <a:srgbClr val="C4B5FD"/>
+                  <a:srgbClr val="A5B4FC"/>
                 </a:solidFill>
                 <a:latin typeface="Courier New" pitchFamily="34" charset="0"/>
                 <a:ea typeface="Courier New" pitchFamily="34" charset="-122"/>
@@ -12841,13 +12841,13 @@
             <a:r>
               <a:rPr lang="en-US" sz="1150" dirty="0">
                 <a:solidFill>
-                  <a:srgbClr val="7DD3FC"/>
+                  <a:srgbClr val="5EEAD4"/>
                 </a:solidFill>
                 <a:latin typeface="Courier New" pitchFamily="34" charset="0"/>
                 <a:ea typeface="Courier New" pitchFamily="34" charset="-122"/>
                 <a:cs typeface="Courier New" pitchFamily="34" charset="-120"/>
               </a:rPr>
-              <a:t>      tools=["Read"]),  # no web -&gt; can't go rogue</a:t>
+              <a:t>      tools=["Read"]),   # 3 scoped: no web</a:t>
             </a:r>
             <a:endParaRPr lang="en-US" sz="1150" dirty="0"/>
           </a:p>
@@ -19888,7 +19888,7 @@
                 <a:ea typeface="Courier New" pitchFamily="34" charset="-122"/>
                 <a:cs typeface="Courier New" pitchFamily="34" charset="-120"/>
               </a:rPr>
-              <a:t>    if amt &gt; 500:                       # 1 rule</a:t>
+              <a:t>    if amt &gt; 500:                      # 1 the rule</a:t>
             </a:r>
             <a:endParaRPr lang="en-US" sz="1250" dirty="0"/>
           </a:p>
@@ -19948,7 +19948,7 @@
                 <a:ea typeface="Courier New" pitchFamily="34" charset="-122"/>
                 <a:cs typeface="Courier New" pitchFamily="34" charset="-120"/>
               </a:rPr>
-              <a:t>        "permissionDecision": "deny",      # 2 block</a:t>
+              <a:t>        "permissionDecision": "deny",     # 2 blocks</a:t>
             </a:r>
             <a:endParaRPr lang="en-US" sz="1250" dirty="0"/>
           </a:p>
@@ -19962,13 +19962,13 @@
             <a:r>
               <a:rPr lang="en-US" sz="1250" dirty="0">
                 <a:solidFill>
-                  <a:srgbClr val="E2E8F0"/>
+                  <a:srgbClr val="A5B4FC"/>
                 </a:solidFill>
                 <a:latin typeface="Courier New" pitchFamily="34" charset="0"/>
                 <a:ea typeface="Courier New" pitchFamily="34" charset="-122"/>
                 <a:cs typeface="Courier New" pitchFamily="34" charset="-120"/>
               </a:rPr>
-              <a:t>        "permissionDecisionReason":          # 3</a:t>
+              <a:t>        "permissionDecisionReason":         # 3 reason</a:t>
             </a:r>
             <a:endParaRPr lang="en-US" sz="1250" dirty="0"/>
           </a:p>
@@ -20063,7 +20063,7 @@
             <a:avLst/>
           </a:prstGeom>
           <a:solidFill>
-            <a:srgbClr val="F43F5E"/>
+            <a:srgbClr val="F59E0B"/>
           </a:solidFill>
           <a:ln/>
         </p:spPr>
@@ -20140,7 +20140,7 @@
                 <a:ea typeface="Calibri" pitchFamily="34" charset="-122"/>
                 <a:cs typeface="Calibri" pitchFamily="34" charset="-120"/>
               </a:rPr>
-              <a:t>deny blocks the call</a:t>
+              <a:t>Match the rule</a:t>
             </a:r>
             <a:endParaRPr lang="en-US" sz="1250" dirty="0"/>
           </a:p>
@@ -20182,7 +20182,7 @@
                 <a:ea typeface="Calibri" pitchFamily="34" charset="-122"/>
                 <a:cs typeface="Calibri" pitchFamily="34" charset="-120"/>
               </a:rPr>
-              <a:t>permissionDecision: allow | deny | ask | defer.</a:t>
+              <a:t>Inspect the args before the tool runs — here, amount &gt; $500.</a:t>
             </a:r>
             <a:endParaRPr lang="en-US" sz="1100" dirty="0"/>
           </a:p>
@@ -20237,7 +20237,7 @@
             <a:avLst/>
           </a:prstGeom>
           <a:solidFill>
-            <a:srgbClr val="4F46E5"/>
+            <a:srgbClr val="F43F5E"/>
           </a:solidFill>
           <a:ln/>
         </p:spPr>
@@ -20314,7 +20314,7 @@
                 <a:ea typeface="Calibri" pitchFamily="34" charset="-122"/>
                 <a:cs typeface="Calibri" pitchFamily="34" charset="-120"/>
               </a:rPr>
-              <a:t>Always give a reason</a:t>
+              <a:t>deny blocks the call</a:t>
             </a:r>
             <a:endParaRPr lang="en-US" sz="1250" dirty="0"/>
           </a:p>
@@ -20356,7 +20356,7 @@
                 <a:ea typeface="Calibri" pitchFamily="34" charset="-122"/>
                 <a:cs typeface="Calibri" pitchFamily="34" charset="-120"/>
               </a:rPr>
-              <a:t>The model sees it and won't blindly retry.</a:t>
+              <a:t>permissionDecision: allow | deny | ask | defer.</a:t>
             </a:r>
             <a:endParaRPr lang="en-US" sz="1100" dirty="0"/>
           </a:p>
@@ -20411,7 +20411,7 @@
             <a:avLst/>
           </a:prstGeom>
           <a:solidFill>
-            <a:srgbClr val="14B8A6"/>
+            <a:srgbClr val="4F46E5"/>
           </a:solidFill>
           <a:ln/>
         </p:spPr>
@@ -20488,7 +20488,7 @@
                 <a:ea typeface="Calibri" pitchFamily="34" charset="-122"/>
                 <a:cs typeface="Calibri" pitchFamily="34" charset="-120"/>
               </a:rPr>
-              <a:t>deny wins</a:t>
+              <a:t>Give a reason</a:t>
             </a:r>
             <a:endParaRPr lang="en-US" sz="1250" dirty="0"/>
           </a:p>
@@ -20530,7 +20530,7 @@
                 <a:ea typeface="Calibri" pitchFamily="34" charset="-122"/>
                 <a:cs typeface="Calibri" pitchFamily="34" charset="-120"/>
               </a:rPr>
-              <a:t>If any hook denies, the call is blocked. Hooks run in parallel.</a:t>
+              <a:t>The model sees it and won't blindly retry. deny always wins if hooks conflict.</a:t>
             </a:r>
             <a:endParaRPr lang="en-US" sz="1100" dirty="0"/>
           </a:p>
@@ -21298,7 +21298,7 @@
             <a:avLst/>
           </a:prstGeom>
           <a:solidFill>
-            <a:srgbClr val="4F46E5"/>
+            <a:srgbClr val="F59E0B"/>
           </a:solidFill>
           <a:ln/>
         </p:spPr>
@@ -21330,7 +21330,7 @@
             <a:r>
               <a:rPr lang="en-US" sz="1150" b="1" dirty="0">
                 <a:solidFill>
-                  <a:srgbClr val="4F46E5"/>
+                  <a:srgbClr val="F59E0B"/>
                 </a:solidFill>
                 <a:latin typeface="Courier New" pitchFamily="34" charset="0"/>
                 <a:ea typeface="Courier New" pitchFamily="34" charset="-122"/>
@@ -21378,7 +21378,7 @@
                 <a:ea typeface="Calibri" pitchFamily="34" charset="-122"/>
                 <a:cs typeface="Calibri" pitchFamily="34" charset="-120"/>
               </a:rPr>
-              <a:t>Append normalized info to the tool result.</a:t>
+              <a:t>Append normalized info to the tool result (matches the highlighted line).</a:t>
             </a:r>
             <a:endParaRPr lang="en-US" sz="1100" dirty="0"/>
           </a:p>
@@ -21433,7 +21433,7 @@
             <a:avLst/>
           </a:prstGeom>
           <a:solidFill>
-            <a:srgbClr val="F59E0B"/>
+            <a:srgbClr val="4F46E5"/>
           </a:solidFill>
           <a:ln/>
         </p:spPr>
@@ -21465,7 +21465,7 @@
             <a:r>
               <a:rPr lang="en-US" sz="1150" b="1" dirty="0">
                 <a:solidFill>
-                  <a:srgbClr val="F59E0B"/>
+                  <a:srgbClr val="4F46E5"/>
                 </a:solidFill>
                 <a:latin typeface="Courier New" pitchFamily="34" charset="0"/>
                 <a:ea typeface="Courier New" pitchFamily="34" charset="-122"/>
@@ -37589,7 +37589,7 @@
                 <a:ea typeface="Courier New" pitchFamily="34" charset="-122"/>
                 <a:cs typeface="Courier New" pitchFamily="34" charset="-120"/>
               </a:rPr>
-              <a:t>    if r.stop_reason == "end_turn":   # 2 DONE</a:t>
+              <a:t>    if r.stop_reason == "end_turn":   # 1 done</a:t>
             </a:r>
             <a:endParaRPr lang="en-US" sz="1250" dirty="0"/>
           </a:p>
@@ -37623,13 +37623,13 @@
             <a:r>
               <a:rPr lang="en-US" sz="1250" dirty="0">
                 <a:solidFill>
-                  <a:srgbClr val="6EE7B7"/>
+                  <a:srgbClr val="5EEAD4"/>
                 </a:solidFill>
                 <a:latin typeface="Courier New" pitchFamily="34" charset="0"/>
                 <a:ea typeface="Courier New" pitchFamily="34" charset="-122"/>
                 <a:cs typeface="Courier New" pitchFamily="34" charset="-120"/>
               </a:rPr>
-              <a:t>    if r.stop_reason == "tool_use":   # 1 CONTINUE</a:t>
+              <a:t>    if r.stop_reason == "tool_use":   # 2 continue</a:t>
             </a:r>
             <a:endParaRPr lang="en-US" sz="1250" dirty="0"/>
           </a:p>
@@ -37683,13 +37683,13 @@
             <a:r>
               <a:rPr lang="en-US" sz="1250" dirty="0">
                 <a:solidFill>
-                  <a:srgbClr val="E2E8F0"/>
+                  <a:srgbClr val="A5B4FC"/>
                 </a:solidFill>
                 <a:latin typeface="Courier New" pitchFamily="34" charset="0"/>
                 <a:ea typeface="Courier New" pitchFamily="34" charset="-122"/>
                 <a:cs typeface="Courier New" pitchFamily="34" charset="-120"/>
               </a:rPr>
-              <a:t>                         "content": results})  # 3</a:t>
+              <a:t>                  "content": results})  # 3 feed back</a:t>
             </a:r>
             <a:endParaRPr lang="en-US" sz="1250" dirty="0"/>
           </a:p>
@@ -37744,7 +37744,7 @@
             <a:avLst/>
           </a:prstGeom>
           <a:solidFill>
-            <a:srgbClr val="14B8A6"/>
+            <a:srgbClr val="F43F5E"/>
           </a:solidFill>
           <a:ln/>
         </p:spPr>
@@ -37821,7 +37821,7 @@
                 <a:ea typeface="Calibri" pitchFamily="34" charset="-122"/>
                 <a:cs typeface="Calibri" pitchFamily="34" charset="-120"/>
               </a:rPr>
-              <a:t>Branch on stop_reason</a:t>
+              <a:t>Terminate on end_turn</a:t>
             </a:r>
             <a:endParaRPr lang="en-US" sz="1350" dirty="0"/>
           </a:p>
@@ -37863,7 +37863,7 @@
                 <a:ea typeface="Calibri" pitchFamily="34" charset="-122"/>
                 <a:cs typeface="Calibri" pitchFamily="34" charset="-120"/>
               </a:rPr>
-              <a:t>tool_use → run tools and loop again.</a:t>
+              <a:t>Return the model's final text — not on assistant text or an iteration cap.</a:t>
             </a:r>
             <a:endParaRPr lang="en-US" sz="1150" dirty="0"/>
           </a:p>
@@ -37918,7 +37918,7 @@
             <a:avLst/>
           </a:prstGeom>
           <a:solidFill>
-            <a:srgbClr val="F43F5E"/>
+            <a:srgbClr val="14B8A6"/>
           </a:solidFill>
           <a:ln/>
         </p:spPr>
@@ -37995,7 +37995,7 @@
                 <a:ea typeface="Calibri" pitchFamily="34" charset="-122"/>
                 <a:cs typeface="Calibri" pitchFamily="34" charset="-120"/>
               </a:rPr>
-              <a:t>Terminate on end_turn</a:t>
+              <a:t>Continue on tool_use</a:t>
             </a:r>
             <a:endParaRPr lang="en-US" sz="1350" dirty="0"/>
           </a:p>
@@ -38037,7 +38037,7 @@
                 <a:ea typeface="Calibri" pitchFamily="34" charset="-122"/>
                 <a:cs typeface="Calibri" pitchFamily="34" charset="-120"/>
               </a:rPr>
-              <a:t>Return the model's final text. Not on text/iteration count.</a:t>
+              <a:t>Run the requested tools, then loop again with the results.</a:t>
             </a:r>
             <a:endParaRPr lang="en-US" sz="1150" dirty="0"/>
           </a:p>

</xml_diff>

<commit_message>
Slide 18: remove duplicate #3 label and neutralize non-annotated lines for cleaner color mapping
</commit_message>
<xml_diff>
--- a/claude-certified-architect/Topic1_Agentic_Apps_Agent_SDK/Agentic_Apps_Claude_Agent_SDK.pptx
+++ b/claude-certified-architect/Topic1_Agentic_Apps_Agent_SDK/Agentic_Apps_Claude_Agent_SDK.pptx
@@ -12721,7 +12721,7 @@
             <a:r>
               <a:rPr lang="en-US" sz="1150" dirty="0">
                 <a:solidFill>
-                  <a:srgbClr val="6EE7B7"/>
+                  <a:srgbClr val="E2E8F0"/>
                 </a:solidFill>
                 <a:latin typeface="Courier New" pitchFamily="34" charset="0"/>
                 <a:ea typeface="Courier New" pitchFamily="34" charset="-122"/>
@@ -12821,7 +12821,7 @@
             <a:r>
               <a:rPr lang="en-US" sz="1150" dirty="0">
                 <a:solidFill>
-                  <a:srgbClr val="6EE7B7"/>
+                  <a:srgbClr val="E2E8F0"/>
                 </a:solidFill>
                 <a:latin typeface="Courier New" pitchFamily="34" charset="0"/>
                 <a:ea typeface="Courier New" pitchFamily="34" charset="-122"/>
@@ -12847,7 +12847,7 @@
                 <a:ea typeface="Courier New" pitchFamily="34" charset="-122"/>
                 <a:cs typeface="Courier New" pitchFamily="34" charset="-120"/>
               </a:rPr>
-              <a:t>      tools=["Read"]),   # 3 scoped: no web</a:t>
+              <a:t>      tools=["Read"]),   # scoped: no web</a:t>
             </a:r>
             <a:endParaRPr lang="en-US" sz="1150" dirty="0"/>
           </a:p>

</xml_diff>